<commit_message>
Align box titles to top on slides 9 and 13
Titles were vertically centered, overlapping with detail text below.
Changed anchor from center to top so titles sit clearly at the top of
each colored box.

https://claude.ai/code/session_014iFkR9q9MZehThwobdktTC
</commit_message>
<xml_diff>
--- a/Cobook_org_final.pptx
+++ b/Cobook_org_final.pptx
@@ -24025,7 +24025,7 @@
           </a:fontRef>
         </p:style>
         <p:txBody>
-          <a:bodyPr wrap="square" rtlCol="0" anchor="ctr"/>
+          <a:bodyPr wrap="square" rtlCol="0" anchor="t" tIns="76200"/>
           <a:lstStyle/>
           <a:p>
             <a:pPr algn="ctr">
@@ -24267,7 +24267,7 @@
           </a:fontRef>
         </p:style>
         <p:txBody>
-          <a:bodyPr wrap="square" rtlCol="0" anchor="ctr"/>
+          <a:bodyPr wrap="square" rtlCol="0" anchor="t" tIns="76200"/>
           <a:lstStyle/>
           <a:p>
             <a:pPr algn="ctr">
@@ -24481,7 +24481,7 @@
           </a:fontRef>
         </p:style>
         <p:txBody>
-          <a:bodyPr wrap="square" rtlCol="0" anchor="ctr"/>
+          <a:bodyPr wrap="square" rtlCol="0" anchor="t" tIns="76200"/>
           <a:lstStyle/>
           <a:p>
             <a:pPr algn="ctr">
@@ -24658,7 +24658,7 @@
           </a:fontRef>
         </p:style>
         <p:txBody>
-          <a:bodyPr wrap="square" rtlCol="0" anchor="ctr"/>
+          <a:bodyPr wrap="square" rtlCol="0" anchor="t" tIns="76200"/>
           <a:lstStyle/>
           <a:p>
             <a:pPr algn="ctr">
@@ -27179,7 +27179,7 @@
           </a:fontRef>
         </p:style>
         <p:txBody>
-          <a:bodyPr wrap="square" rtlCol="0" anchor="ctr"/>
+          <a:bodyPr wrap="square" rtlCol="0" anchor="t" tIns="76200"/>
           <a:lstStyle/>
           <a:p>
             <a:pPr algn="ctr">
@@ -27380,7 +27380,7 @@
           </a:fontRef>
         </p:style>
         <p:txBody>
-          <a:bodyPr wrap="square" rtlCol="0" anchor="ctr"/>
+          <a:bodyPr wrap="square" rtlCol="0" anchor="t" tIns="76200"/>
           <a:lstStyle/>
           <a:p>
             <a:pPr algn="ctr">
@@ -27637,7 +27637,7 @@
           </a:fontRef>
         </p:style>
         <p:txBody>
-          <a:bodyPr wrap="square" rtlCol="0" anchor="ctr"/>
+          <a:bodyPr wrap="square" rtlCol="0" anchor="t" tIns="76200"/>
           <a:lstStyle/>
           <a:p>
             <a:pPr algn="ctr">
@@ -27863,7 +27863,7 @@
           </a:fontRef>
         </p:style>
         <p:txBody>
-          <a:bodyPr wrap="square" rtlCol="0" anchor="ctr"/>
+          <a:bodyPr wrap="square" rtlCol="0" anchor="t" tIns="76200"/>
           <a:lstStyle/>
           <a:p>
             <a:pPr algn="ctr">
@@ -28007,7 +28007,7 @@
           </a:fontRef>
         </p:style>
         <p:txBody>
-          <a:bodyPr wrap="square" rtlCol="0" anchor="ctr"/>
+          <a:bodyPr wrap="square" rtlCol="0" anchor="t" tIns="76200"/>
           <a:lstStyle/>
           <a:p>
             <a:pPr algn="ctr">
@@ -28167,7 +28167,7 @@
           </a:fontRef>
         </p:style>
         <p:txBody>
-          <a:bodyPr wrap="square" rtlCol="0" anchor="ctr"/>
+          <a:bodyPr wrap="square" rtlCol="0" anchor="t" tIns="76200"/>
           <a:lstStyle/>
           <a:p>
             <a:pPr algn="ctr">
@@ -28328,7 +28328,7 @@
           </a:fontRef>
         </p:style>
         <p:txBody>
-          <a:bodyPr wrap="square" rtlCol="0" anchor="ctr"/>
+          <a:bodyPr wrap="square" rtlCol="0" anchor="t" tIns="76200"/>
           <a:lstStyle/>
           <a:p>
             <a:pPr algn="ctr">

</xml_diff>

<commit_message>
Merge box titles and detail text into single shapes on slides 9 & 13
Title at top of each colored box, detail text below — all white text,
no more separate overlapping textboxes. Cleaner and more readable.

https://claude.ai/code/session_014iFkR9q9MZehThwobdktTC
</commit_message>
<xml_diff>
--- a/Cobook_org_final.pptx
+++ b/Cobook_org_final.pptx
@@ -24051,138 +24051,131 @@
               <a:t>Matrice R (creuse)</a:t>
             </a:r>
           </a:p>
-        </p:txBody>
-      </p:sp>
-      <p:sp>
-        <p:nvSpPr>
-          <p:cNvPr id="4" name="TextBox 3"/>
-          <p:cNvSpPr txBox="1"/>
-          <p:nvPr/>
-        </p:nvSpPr>
-        <p:spPr>
-          <a:xfrm>
-            <a:off x="822960" y="2066544"/>
-            <a:ext cx="3291840" cy="1188720"/>
-          </a:xfrm>
-          <a:prstGeom prst="rect">
-            <a:avLst/>
-          </a:prstGeom>
-          <a:noFill/>
-        </p:spPr>
-        <p:txBody>
-          <a:bodyPr wrap="square">
-            <a:spAutoFit/>
-          </a:bodyPr>
-          <a:lstStyle/>
-          <a:p>
-            <a:pPr algn="l">
-              <a:defRPr sz="1100" b="0">
-                <a:solidFill>
-                  <a:srgbClr val="333333"/>
-                </a:solidFill>
-                <a:latin typeface="Consolas"/>
-              </a:defRPr>
-            </a:pPr>
-            <a:r>
-              <a:rPr lang="fr-FR" noProof="0" dirty="0">
-                <a:solidFill>
-                  <a:srgbClr val="FFFFFF"/>
-                </a:solidFill>
-              </a:rPr>
-              <a:t>         p1    p2    p3    p4</a:t>
-            </a:r>
-          </a:p>
-          <a:p>
-            <a:pPr algn="l">
-              <a:spcBef>
-                <a:spcPts val="100"/>
-              </a:spcBef>
-              <a:spcAft>
-                <a:spcPts val="200"/>
-              </a:spcAft>
-              <a:defRPr sz="1100" b="0">
-                <a:solidFill>
-                  <a:srgbClr val="333333"/>
-                </a:solidFill>
-                <a:latin typeface="Consolas"/>
-              </a:defRPr>
-            </a:pPr>
-            <a:r>
-              <a:rPr lang="fr-FR" noProof="0" dirty="0">
-                <a:solidFill>
-                  <a:srgbClr val="FFFFFF"/>
-                </a:solidFill>
-              </a:rPr>
-              <a:t>u1   4.0    ?    3.2    ?</a:t>
-            </a:r>
-          </a:p>
-          <a:p>
-            <a:pPr algn="l">
-              <a:spcBef>
-                <a:spcPts val="100"/>
-              </a:spcBef>
-              <a:spcAft>
-                <a:spcPts val="200"/>
-              </a:spcAft>
-              <a:defRPr sz="1100" b="0">
-                <a:solidFill>
-                  <a:srgbClr val="333333"/>
-                </a:solidFill>
-                <a:latin typeface="Consolas"/>
-              </a:defRPr>
-            </a:pPr>
-            <a:r>
-              <a:rPr lang="fr-FR" noProof="0" dirty="0">
-                <a:solidFill>
-                  <a:srgbClr val="FFFFFF"/>
-                </a:solidFill>
-              </a:rPr>
-              <a:t>u2    ?    5.0    ?    2.1</a:t>
-            </a:r>
-          </a:p>
-          <a:p>
-            <a:pPr algn="l">
-              <a:spcBef>
-                <a:spcPts val="100"/>
-              </a:spcBef>
-              <a:spcAft>
-                <a:spcPts val="200"/>
-              </a:spcAft>
-              <a:defRPr sz="1100" b="0">
-                <a:solidFill>
-                  <a:srgbClr val="333333"/>
-                </a:solidFill>
-                <a:latin typeface="Consolas"/>
-              </a:defRPr>
-            </a:pPr>
-            <a:r>
-              <a:rPr lang="fr-FR" noProof="0" dirty="0">
-                <a:solidFill>
-                  <a:srgbClr val="FFFFFF"/>
-                </a:solidFill>
-              </a:rPr>
-              <a:t>u3   1.5    ?     ?    4.0</a:t>
-            </a:r>
-          </a:p>
-          <a:p>
-            <a:pPr algn="l">
+          <a:p>
+            <a:pPr>
               <a:spcBef>
                 <a:spcPts val="400"/>
               </a:spcBef>
               <a:spcAft>
                 <a:spcPts val="200"/>
               </a:spcAft>
-              <a:defRPr sz="1000" b="0">
-                <a:solidFill>
-                  <a:srgbClr val="888888"/>
+            </a:pPr>
+          </a:p>
+          <a:p>
+            <a:pPr algn="ctr">
+              <a:spcBef>
+                <a:spcPts val="100"/>
+              </a:spcBef>
+              <a:spcAft>
+                <a:spcPts val="100"/>
+              </a:spcAft>
+              <a:defRPr sz="1100" b="0">
+                <a:solidFill>
+                  <a:srgbClr val="E0E0E0"/>
                 </a:solidFill>
                 <a:latin typeface="Calibri"/>
               </a:defRPr>
             </a:pPr>
             <a:r>
-              <a:rPr lang="fr-FR" noProof="0" dirty="0">
-                <a:solidFill>
-                  <a:srgbClr val="FFFFFF"/>
+              <a:rPr>
+                <a:solidFill>
+                  <a:srgbClr val="E8E8E8"/>
+                </a:solidFill>
+              </a:rPr>
+              <a:t>p1    p2    p3    p4</a:t>
+            </a:r>
+          </a:p>
+          <a:p>
+            <a:pPr algn="ctr">
+              <a:spcBef>
+                <a:spcPts val="100"/>
+              </a:spcBef>
+              <a:spcAft>
+                <a:spcPts val="100"/>
+              </a:spcAft>
+              <a:defRPr sz="1100" b="0">
+                <a:solidFill>
+                  <a:srgbClr val="E0E0E0"/>
+                </a:solidFill>
+                <a:latin typeface="Calibri"/>
+              </a:defRPr>
+            </a:pPr>
+            <a:r>
+              <a:rPr>
+                <a:solidFill>
+                  <a:srgbClr val="E8E8E8"/>
+                </a:solidFill>
+              </a:rPr>
+              <a:t>u1   4.0    ?    3.2    ?</a:t>
+            </a:r>
+          </a:p>
+          <a:p>
+            <a:pPr algn="ctr">
+              <a:spcBef>
+                <a:spcPts val="100"/>
+              </a:spcBef>
+              <a:spcAft>
+                <a:spcPts val="100"/>
+              </a:spcAft>
+              <a:defRPr sz="1100" b="0">
+                <a:solidFill>
+                  <a:srgbClr val="E0E0E0"/>
+                </a:solidFill>
+                <a:latin typeface="Calibri"/>
+              </a:defRPr>
+            </a:pPr>
+            <a:r>
+              <a:rPr>
+                <a:solidFill>
+                  <a:srgbClr val="E8E8E8"/>
+                </a:solidFill>
+              </a:rPr>
+              <a:t>u2    ?    5.0    ?    2.1</a:t>
+            </a:r>
+          </a:p>
+          <a:p>
+            <a:pPr algn="ctr">
+              <a:spcBef>
+                <a:spcPts val="100"/>
+              </a:spcBef>
+              <a:spcAft>
+                <a:spcPts val="100"/>
+              </a:spcAft>
+              <a:defRPr sz="1100" b="0">
+                <a:solidFill>
+                  <a:srgbClr val="E0E0E0"/>
+                </a:solidFill>
+                <a:latin typeface="Calibri"/>
+              </a:defRPr>
+            </a:pPr>
+            <a:r>
+              <a:rPr>
+                <a:solidFill>
+                  <a:srgbClr val="E8E8E8"/>
+                </a:solidFill>
+              </a:rPr>
+              <a:t>u3   1.5    ?     ?    4.0</a:t>
+            </a:r>
+          </a:p>
+          <a:p>
+            <a:pPr algn="ctr">
+              <a:spcBef>
+                <a:spcPts val="100"/>
+              </a:spcBef>
+              <a:spcAft>
+                <a:spcPts val="100"/>
+              </a:spcAft>
+              <a:defRPr sz="1100" b="0">
+                <a:solidFill>
+                  <a:srgbClr val="E0E0E0"/>
+                </a:solidFill>
+                <a:latin typeface="Calibri"/>
+              </a:defRPr>
+            </a:pPr>
+            <a:r>
+              <a:rPr>
+                <a:solidFill>
+                  <a:srgbClr val="E8E8E8"/>
                 </a:solidFill>
               </a:rPr>
               <a:t>? = inconnu (~65% de la matrice)</a:t>
@@ -24293,114 +24286,107 @@
               <a:t>U (utilisateurs, k=2)</a:t>
             </a:r>
           </a:p>
-        </p:txBody>
-      </p:sp>
-      <p:sp>
-        <p:nvSpPr>
-          <p:cNvPr id="7" name="TextBox 6"/>
-          <p:cNvSpPr txBox="1"/>
-          <p:nvPr/>
-        </p:nvSpPr>
-        <p:spPr>
-          <a:xfrm>
-            <a:off x="4572000" y="2194560"/>
-            <a:ext cx="2834640" cy="1097280"/>
-          </a:xfrm>
-          <a:prstGeom prst="rect">
-            <a:avLst/>
-          </a:prstGeom>
-          <a:noFill/>
-        </p:spPr>
-        <p:txBody>
-          <a:bodyPr wrap="square">
-            <a:spAutoFit/>
-          </a:bodyPr>
-          <a:lstStyle/>
-          <a:p>
-            <a:pPr algn="l">
-              <a:defRPr sz="1100" b="0">
-                <a:solidFill>
-                  <a:srgbClr val="333333"/>
-                </a:solidFill>
-                <a:latin typeface="Consolas"/>
-              </a:defRPr>
-            </a:pPr>
-            <a:r>
-              <a:rPr lang="fr-FR" noProof="0" dirty="0">
-                <a:solidFill>
-                  <a:srgbClr val="FFFFFF"/>
-                </a:solidFill>
-              </a:rPr>
-              <a:t>u1  [0.9,  0.8]</a:t>
-            </a:r>
-          </a:p>
-          <a:p>
-            <a:pPr algn="l">
-              <a:spcBef>
-                <a:spcPts val="100"/>
-              </a:spcBef>
-              <a:spcAft>
-                <a:spcPts val="200"/>
-              </a:spcAft>
-              <a:defRPr sz="1100" b="0">
-                <a:solidFill>
-                  <a:srgbClr val="333333"/>
-                </a:solidFill>
-                <a:latin typeface="Consolas"/>
-              </a:defRPr>
-            </a:pPr>
-            <a:r>
-              <a:rPr lang="fr-FR" noProof="0" dirty="0">
-                <a:solidFill>
-                  <a:srgbClr val="FFFFFF"/>
-                </a:solidFill>
-              </a:rPr>
-              <a:t>u2  [0.7, -0.5]</a:t>
-            </a:r>
-          </a:p>
-          <a:p>
-            <a:pPr algn="l">
-              <a:spcBef>
-                <a:spcPts val="100"/>
-              </a:spcBef>
-              <a:spcAft>
-                <a:spcPts val="200"/>
-              </a:spcAft>
-              <a:defRPr sz="1100" b="0">
-                <a:solidFill>
-                  <a:srgbClr val="333333"/>
-                </a:solidFill>
-                <a:latin typeface="Consolas"/>
-              </a:defRPr>
-            </a:pPr>
-            <a:r>
-              <a:rPr lang="fr-FR" noProof="0" dirty="0">
-                <a:solidFill>
-                  <a:srgbClr val="FFFFFF"/>
-                </a:solidFill>
-              </a:rPr>
-              <a:t>u3  [-0.6, 0.9]</a:t>
-            </a:r>
-          </a:p>
-          <a:p>
-            <a:pPr algn="l">
+          <a:p>
+            <a:pPr>
               <a:spcBef>
                 <a:spcPts val="400"/>
               </a:spcBef>
               <a:spcAft>
                 <a:spcPts val="200"/>
               </a:spcAft>
-              <a:defRPr sz="1000" b="0">
-                <a:solidFill>
-                  <a:srgbClr val="888888"/>
+            </a:pPr>
+          </a:p>
+          <a:p>
+            <a:pPr algn="ctr">
+              <a:spcBef>
+                <a:spcPts val="100"/>
+              </a:spcBef>
+              <a:spcAft>
+                <a:spcPts val="100"/>
+              </a:spcAft>
+              <a:defRPr sz="1100" b="0">
+                <a:solidFill>
+                  <a:srgbClr val="E0E0E0"/>
                 </a:solidFill>
                 <a:latin typeface="Calibri"/>
               </a:defRPr>
             </a:pPr>
             <a:r>
-              <a:rPr lang="fr-FR" noProof="0" dirty="0">
-                <a:solidFill>
-                  <a:srgbClr val="FFFFFF"/>
+              <a:rPr>
+                <a:solidFill>
+                  <a:srgbClr val="E8E8E8"/>
+                </a:solidFill>
+              </a:rPr>
+              <a:t>u1  [0.9,  0.8]</a:t>
+            </a:r>
+          </a:p>
+          <a:p>
+            <a:pPr algn="ctr">
+              <a:spcBef>
+                <a:spcPts val="100"/>
+              </a:spcBef>
+              <a:spcAft>
+                <a:spcPts val="100"/>
+              </a:spcAft>
+              <a:defRPr sz="1100" b="0">
+                <a:solidFill>
+                  <a:srgbClr val="E0E0E0"/>
+                </a:solidFill>
+                <a:latin typeface="Calibri"/>
+              </a:defRPr>
+            </a:pPr>
+            <a:r>
+              <a:rPr>
+                <a:solidFill>
+                  <a:srgbClr val="E8E8E8"/>
+                </a:solidFill>
+              </a:rPr>
+              <a:t>u2  [0.7, -0.5]</a:t>
+            </a:r>
+          </a:p>
+          <a:p>
+            <a:pPr algn="ctr">
+              <a:spcBef>
+                <a:spcPts val="100"/>
+              </a:spcBef>
+              <a:spcAft>
+                <a:spcPts val="100"/>
+              </a:spcAft>
+              <a:defRPr sz="1100" b="0">
+                <a:solidFill>
+                  <a:srgbClr val="E0E0E0"/>
+                </a:solidFill>
+                <a:latin typeface="Calibri"/>
+              </a:defRPr>
+            </a:pPr>
+            <a:r>
+              <a:rPr>
+                <a:solidFill>
+                  <a:srgbClr val="E8E8E8"/>
+                </a:solidFill>
+              </a:rPr>
+              <a:t>u3  [-0.6, 0.9]</a:t>
+            </a:r>
+          </a:p>
+          <a:p>
+            <a:pPr algn="ctr">
+              <a:spcBef>
+                <a:spcPts val="100"/>
+              </a:spcBef>
+              <a:spcAft>
+                <a:spcPts val="100"/>
+              </a:spcAft>
+              <a:defRPr sz="1100" b="0">
+                <a:solidFill>
+                  <a:srgbClr val="E0E0E0"/>
+                </a:solidFill>
+                <a:latin typeface="Calibri"/>
+              </a:defRPr>
+            </a:pPr>
+            <a:r>
+              <a:rPr>
+                <a:solidFill>
+                  <a:srgbClr val="E8E8E8"/>
                 </a:solidFill>
               </a:rPr>
               <a:t>Chaque ligne = goût utilisateur</a:t>
@@ -24507,114 +24493,107 @@
               <a:t>Vᵀ (items, k=2)</a:t>
             </a:r>
           </a:p>
-        </p:txBody>
-      </p:sp>
-      <p:sp>
-        <p:nvSpPr>
-          <p:cNvPr id="10" name="TextBox 9"/>
-          <p:cNvSpPr txBox="1"/>
-          <p:nvPr/>
-        </p:nvSpPr>
-        <p:spPr>
-          <a:xfrm>
-            <a:off x="8229600" y="2194560"/>
-            <a:ext cx="3291840" cy="1097280"/>
-          </a:xfrm>
-          <a:prstGeom prst="rect">
-            <a:avLst/>
-          </a:prstGeom>
-          <a:noFill/>
-        </p:spPr>
-        <p:txBody>
-          <a:bodyPr wrap="square">
-            <a:spAutoFit/>
-          </a:bodyPr>
-          <a:lstStyle/>
-          <a:p>
-            <a:pPr algn="l">
-              <a:defRPr sz="1100" b="0">
-                <a:solidFill>
-                  <a:srgbClr val="333333"/>
-                </a:solidFill>
-                <a:latin typeface="Consolas"/>
-              </a:defRPr>
-            </a:pPr>
-            <a:r>
-              <a:rPr lang="fr-FR" noProof="0" dirty="0">
-                <a:solidFill>
-                  <a:srgbClr val="FFFFFF"/>
-                </a:solidFill>
-              </a:rPr>
-              <a:t>p1  [ 0.9, -0.3]</a:t>
-            </a:r>
-          </a:p>
-          <a:p>
-            <a:pPr algn="l">
-              <a:spcBef>
-                <a:spcPts val="100"/>
-              </a:spcBef>
-              <a:spcAft>
-                <a:spcPts val="200"/>
-              </a:spcAft>
-              <a:defRPr sz="1100" b="0">
-                <a:solidFill>
-                  <a:srgbClr val="333333"/>
-                </a:solidFill>
-                <a:latin typeface="Consolas"/>
-              </a:defRPr>
-            </a:pPr>
-            <a:r>
-              <a:rPr lang="fr-FR" noProof="0" dirty="0">
-                <a:solidFill>
-                  <a:srgbClr val="FFFFFF"/>
-                </a:solidFill>
-              </a:rPr>
-              <a:t>p2  [ 0.8,  0.1]</a:t>
-            </a:r>
-          </a:p>
-          <a:p>
-            <a:pPr algn="l">
-              <a:spcBef>
-                <a:spcPts val="100"/>
-              </a:spcBef>
-              <a:spcAft>
-                <a:spcPts val="200"/>
-              </a:spcAft>
-              <a:defRPr sz="1100" b="0">
-                <a:solidFill>
-                  <a:srgbClr val="333333"/>
-                </a:solidFill>
-                <a:latin typeface="Consolas"/>
-              </a:defRPr>
-            </a:pPr>
-            <a:r>
-              <a:rPr lang="fr-FR" noProof="0" dirty="0">
-                <a:solidFill>
-                  <a:srgbClr val="FFFFFF"/>
-                </a:solidFill>
-              </a:rPr>
-              <a:t>p3  [ 0.5,  0.9]</a:t>
-            </a:r>
-          </a:p>
-          <a:p>
-            <a:pPr algn="l">
+          <a:p>
+            <a:pPr>
               <a:spcBef>
                 <a:spcPts val="400"/>
               </a:spcBef>
               <a:spcAft>
                 <a:spcPts val="200"/>
               </a:spcAft>
-              <a:defRPr sz="1000" b="0">
-                <a:solidFill>
-                  <a:srgbClr val="888888"/>
+            </a:pPr>
+          </a:p>
+          <a:p>
+            <a:pPr algn="ctr">
+              <a:spcBef>
+                <a:spcPts val="100"/>
+              </a:spcBef>
+              <a:spcAft>
+                <a:spcPts val="100"/>
+              </a:spcAft>
+              <a:defRPr sz="1100" b="0">
+                <a:solidFill>
+                  <a:srgbClr val="E0E0E0"/>
                 </a:solidFill>
                 <a:latin typeface="Calibri"/>
               </a:defRPr>
             </a:pPr>
             <a:r>
-              <a:rPr lang="fr-FR" noProof="0" dirty="0">
-                <a:solidFill>
-                  <a:srgbClr val="FFFFFF"/>
+              <a:rPr>
+                <a:solidFill>
+                  <a:srgbClr val="E8E8E8"/>
+                </a:solidFill>
+              </a:rPr>
+              <a:t>p1  [ 0.9, -0.3]</a:t>
+            </a:r>
+          </a:p>
+          <a:p>
+            <a:pPr algn="ctr">
+              <a:spcBef>
+                <a:spcPts val="100"/>
+              </a:spcBef>
+              <a:spcAft>
+                <a:spcPts val="100"/>
+              </a:spcAft>
+              <a:defRPr sz="1100" b="0">
+                <a:solidFill>
+                  <a:srgbClr val="E0E0E0"/>
+                </a:solidFill>
+                <a:latin typeface="Calibri"/>
+              </a:defRPr>
+            </a:pPr>
+            <a:r>
+              <a:rPr>
+                <a:solidFill>
+                  <a:srgbClr val="E8E8E8"/>
+                </a:solidFill>
+              </a:rPr>
+              <a:t>p2  [ 0.8,  0.1]</a:t>
+            </a:r>
+          </a:p>
+          <a:p>
+            <a:pPr algn="ctr">
+              <a:spcBef>
+                <a:spcPts val="100"/>
+              </a:spcBef>
+              <a:spcAft>
+                <a:spcPts val="100"/>
+              </a:spcAft>
+              <a:defRPr sz="1100" b="0">
+                <a:solidFill>
+                  <a:srgbClr val="E0E0E0"/>
+                </a:solidFill>
+                <a:latin typeface="Calibri"/>
+              </a:defRPr>
+            </a:pPr>
+            <a:r>
+              <a:rPr>
+                <a:solidFill>
+                  <a:srgbClr val="E8E8E8"/>
+                </a:solidFill>
+              </a:rPr>
+              <a:t>p3  [ 0.5,  0.9]</a:t>
+            </a:r>
+          </a:p>
+          <a:p>
+            <a:pPr algn="ctr">
+              <a:spcBef>
+                <a:spcPts val="100"/>
+              </a:spcBef>
+              <a:spcAft>
+                <a:spcPts val="100"/>
+              </a:spcAft>
+              <a:defRPr sz="1100" b="0">
+                <a:solidFill>
+                  <a:srgbClr val="E0E0E0"/>
+                </a:solidFill>
+                <a:latin typeface="Calibri"/>
+              </a:defRPr>
+            </a:pPr>
+            <a:r>
+              <a:rPr>
+                <a:solidFill>
+                  <a:srgbClr val="E8E8E8"/>
                 </a:solidFill>
               </a:rPr>
               <a:t>Chaque ligne = caractéristiques item</a:t>
@@ -27205,138 +27184,131 @@
               <a:t>Sources de Données</a:t>
             </a:r>
           </a:p>
-        </p:txBody>
-      </p:sp>
-      <p:sp>
-        <p:nvSpPr>
-          <p:cNvPr id="4" name="TextBox 3"/>
-          <p:cNvSpPr txBox="1"/>
-          <p:nvPr/>
-        </p:nvSpPr>
-        <p:spPr>
-          <a:xfrm>
-            <a:off x="914400" y="2136038"/>
-            <a:ext cx="3108960" cy="1371600"/>
-          </a:xfrm>
-          <a:prstGeom prst="rect">
-            <a:avLst/>
-          </a:prstGeom>
-          <a:noFill/>
-        </p:spPr>
-        <p:txBody>
-          <a:bodyPr wrap="square">
-            <a:spAutoFit/>
-          </a:bodyPr>
-          <a:lstStyle/>
-          <a:p>
-            <a:pPr algn="l">
-              <a:defRPr sz="1200" b="0">
-                <a:solidFill>
-                  <a:srgbClr val="333333"/>
-                </a:solidFill>
-                <a:latin typeface="Calibri"/>
-              </a:defRPr>
-            </a:pPr>
-            <a:r>
-              <a:rPr lang="fr-FR" noProof="0" dirty="0">
-                <a:solidFill>
-                  <a:srgbClr val="FFFFFF"/>
-                </a:solidFill>
-              </a:rPr>
-              <a:t>Ratings explicites (1-5 étoiles)</a:t>
-            </a:r>
-          </a:p>
-          <a:p>
-            <a:pPr algn="l">
+          <a:p>
+            <a:pPr>
               <a:spcBef>
                 <a:spcPts val="400"/>
               </a:spcBef>
               <a:spcAft>
                 <a:spcPts val="200"/>
               </a:spcAft>
-              <a:defRPr sz="1200" b="0">
-                <a:solidFill>
-                  <a:srgbClr val="333333"/>
+            </a:pPr>
+          </a:p>
+          <a:p>
+            <a:pPr algn="ctr">
+              <a:spcBef>
+                <a:spcPts val="100"/>
+              </a:spcBef>
+              <a:spcAft>
+                <a:spcPts val="100"/>
+              </a:spcAft>
+              <a:defRPr sz="1100" b="0">
+                <a:solidFill>
+                  <a:srgbClr val="E0E0E0"/>
                 </a:solidFill>
                 <a:latin typeface="Calibri"/>
               </a:defRPr>
             </a:pPr>
             <a:r>
-              <a:rPr lang="fr-FR" noProof="0" dirty="0">
-                <a:solidFill>
-                  <a:srgbClr val="FFFFFF"/>
+              <a:rPr>
+                <a:solidFill>
+                  <a:srgbClr val="E8E8E8"/>
                 </a:solidFill>
               </a:rPr>
-              <a:t>~35 000 avis utilisateurs</a:t>
-            </a:r>
-          </a:p>
-          <a:p>
-            <a:pPr algn="l">
+              <a:t>Ratings explicites (1-5 étoiles)</a:t>
+            </a:r>
+          </a:p>
+          <a:p>
+            <a:pPr algn="ctr">
               <a:spcBef>
-                <a:spcPts val="400"/>
+                <a:spcPts val="100"/>
               </a:spcBef>
               <a:spcAft>
-                <a:spcPts val="200"/>
+                <a:spcPts val="100"/>
               </a:spcAft>
-              <a:defRPr sz="1200" b="1">
-                <a:solidFill>
-                  <a:srgbClr val="333333"/>
+              <a:defRPr sz="1100" b="0">
+                <a:solidFill>
+                  <a:srgbClr val="E0E0E0"/>
                 </a:solidFill>
                 <a:latin typeface="Calibri"/>
               </a:defRPr>
             </a:pPr>
             <a:r>
-              <a:rPr lang="fr-FR" noProof="0" dirty="0">
-                <a:solidFill>
-                  <a:srgbClr val="FFFFFF"/>
+              <a:rPr>
+                <a:solidFill>
+                  <a:srgbClr val="E8E8E8"/>
                 </a:solidFill>
               </a:rPr>
-              <a:t>Feedback implicite (durée)</a:t>
-            </a:r>
-          </a:p>
-          <a:p>
-            <a:pPr algn="l">
+              <a:t>~35 000 avis utilisateurs</a:t>
+            </a:r>
+          </a:p>
+          <a:p>
+            <a:pPr algn="ctr">
               <a:spcBef>
-                <a:spcPts val="400"/>
+                <a:spcPts val="100"/>
               </a:spcBef>
               <a:spcAft>
-                <a:spcPts val="200"/>
+                <a:spcPts val="100"/>
               </a:spcAft>
-              <a:defRPr sz="1200" b="0">
-                <a:solidFill>
-                  <a:srgbClr val="333333"/>
+              <a:defRPr sz="1100" b="0">
+                <a:solidFill>
+                  <a:srgbClr val="E0E0E0"/>
                 </a:solidFill>
                 <a:latin typeface="Calibri"/>
               </a:defRPr>
             </a:pPr>
             <a:r>
-              <a:rPr lang="fr-FR" noProof="0" dirty="0">
-                <a:solidFill>
-                  <a:srgbClr val="FFFFFF"/>
+              <a:rPr>
+                <a:solidFill>
+                  <a:srgbClr val="E8E8E8"/>
                 </a:solidFill>
               </a:rPr>
-              <a:t>Durée navigation → échelle log</a:t>
-            </a:r>
-          </a:p>
-          <a:p>
-            <a:pPr algn="l">
+              <a:t>Feedback implicite (durée)</a:t>
+            </a:r>
+          </a:p>
+          <a:p>
+            <a:pPr algn="ctr">
               <a:spcBef>
-                <a:spcPts val="400"/>
+                <a:spcPts val="100"/>
               </a:spcBef>
               <a:spcAft>
-                <a:spcPts val="200"/>
+                <a:spcPts val="100"/>
               </a:spcAft>
-              <a:defRPr sz="1200" b="0">
-                <a:solidFill>
-                  <a:srgbClr val="333333"/>
+              <a:defRPr sz="1100" b="0">
+                <a:solidFill>
+                  <a:srgbClr val="E0E0E0"/>
                 </a:solidFill>
                 <a:latin typeface="Calibri"/>
               </a:defRPr>
             </a:pPr>
             <a:r>
-              <a:rPr lang="fr-FR" noProof="0" dirty="0">
-                <a:solidFill>
-                  <a:srgbClr val="FFFFFF"/>
+              <a:rPr>
+                <a:solidFill>
+                  <a:srgbClr val="E8E8E8"/>
+                </a:solidFill>
+              </a:rPr>
+              <a:t>Durée navigation → échelle log</a:t>
+            </a:r>
+          </a:p>
+          <a:p>
+            <a:pPr algn="ctr">
+              <a:spcBef>
+                <a:spcPts val="100"/>
+              </a:spcBef>
+              <a:spcAft>
+                <a:spcPts val="100"/>
+              </a:spcAft>
+              <a:defRPr sz="1100" b="0">
+                <a:solidFill>
+                  <a:srgbClr val="E0E0E0"/>
+                </a:solidFill>
+                <a:latin typeface="Calibri"/>
+              </a:defRPr>
+            </a:pPr>
+            <a:r>
+              <a:rPr>
+                <a:solidFill>
+                  <a:srgbClr val="E8E8E8"/>
                 </a:solidFill>
               </a:rPr>
               <a:t>Converti en scores 1.0-4.0</a:t>
@@ -27406,194 +27378,131 @@
               <a:t>Configuration</a:t>
             </a:r>
           </a:p>
-        </p:txBody>
-      </p:sp>
-      <p:sp>
-        <p:nvSpPr>
-          <p:cNvPr id="6" name="TextBox 5"/>
-          <p:cNvSpPr txBox="1"/>
-          <p:nvPr/>
-        </p:nvSpPr>
-        <p:spPr>
-          <a:xfrm>
-            <a:off x="4389120" y="2194560"/>
-            <a:ext cx="3108960" cy="1371600"/>
-          </a:xfrm>
-          <a:prstGeom prst="rect">
-            <a:avLst/>
-          </a:prstGeom>
-          <a:noFill/>
-        </p:spPr>
-        <p:txBody>
-          <a:bodyPr wrap="square">
-            <a:spAutoFit/>
-          </a:bodyPr>
-          <a:lstStyle/>
-          <a:p>
-            <a:pPr algn="l">
-              <a:defRPr sz="1200" b="0">
-                <a:solidFill>
-                  <a:srgbClr val="333333"/>
-                </a:solidFill>
-                <a:latin typeface="Calibri"/>
-              </a:defRPr>
-            </a:pPr>
-            <a:r>
-              <a:rPr lang="fr-FR" noProof="0" dirty="0" err="1">
-                <a:solidFill>
-                  <a:srgbClr val="FFFFFF"/>
-                </a:solidFill>
-              </a:rPr>
-              <a:t>Optimizer</a:t>
-            </a:r>
-            <a:r>
-              <a:rPr lang="fr-FR" noProof="0" dirty="0">
-                <a:solidFill>
-                  <a:srgbClr val="FFFFFF"/>
-                </a:solidFill>
-              </a:rPr>
-              <a:t>: Adam (</a:t>
-            </a:r>
-            <a:r>
-              <a:rPr lang="fr-FR" noProof="0" dirty="0" err="1">
-                <a:solidFill>
-                  <a:srgbClr val="FFFFFF"/>
-                </a:solidFill>
-              </a:rPr>
-              <a:t>lr</a:t>
-            </a:r>
-            <a:r>
-              <a:rPr lang="fr-FR" noProof="0" dirty="0">
-                <a:solidFill>
-                  <a:srgbClr val="FFFFFF"/>
-                </a:solidFill>
-              </a:rPr>
-              <a:t>=1e-3)</a:t>
-            </a:r>
-          </a:p>
-          <a:p>
-            <a:pPr algn="l">
+          <a:p>
+            <a:pPr>
               <a:spcBef>
                 <a:spcPts val="400"/>
               </a:spcBef>
               <a:spcAft>
                 <a:spcPts val="200"/>
               </a:spcAft>
-              <a:defRPr sz="1200" b="0">
-                <a:solidFill>
-                  <a:srgbClr val="333333"/>
+            </a:pPr>
+          </a:p>
+          <a:p>
+            <a:pPr algn="ctr">
+              <a:spcBef>
+                <a:spcPts val="100"/>
+              </a:spcBef>
+              <a:spcAft>
+                <a:spcPts val="100"/>
+              </a:spcAft>
+              <a:defRPr sz="1100" b="0">
+                <a:solidFill>
+                  <a:srgbClr val="E0E0E0"/>
                 </a:solidFill>
                 <a:latin typeface="Calibri"/>
               </a:defRPr>
             </a:pPr>
             <a:r>
-              <a:rPr lang="fr-FR" noProof="0" dirty="0">
-                <a:solidFill>
-                  <a:srgbClr val="FFFFFF"/>
+              <a:rPr>
+                <a:solidFill>
+                  <a:srgbClr val="E8E8E8"/>
                 </a:solidFill>
               </a:rPr>
-              <a:t>Loss: MSE (régression)</a:t>
-            </a:r>
-          </a:p>
-          <a:p>
-            <a:pPr algn="l">
+              <a:t>Optimizer: Adam (lr=1e-3)</a:t>
+            </a:r>
+          </a:p>
+          <a:p>
+            <a:pPr algn="ctr">
               <a:spcBef>
-                <a:spcPts val="400"/>
+                <a:spcPts val="100"/>
               </a:spcBef>
               <a:spcAft>
-                <a:spcPts val="200"/>
+                <a:spcPts val="100"/>
               </a:spcAft>
-              <a:defRPr sz="1200" b="0">
-                <a:solidFill>
-                  <a:srgbClr val="333333"/>
+              <a:defRPr sz="1100" b="0">
+                <a:solidFill>
+                  <a:srgbClr val="E0E0E0"/>
                 </a:solidFill>
                 <a:latin typeface="Calibri"/>
               </a:defRPr>
             </a:pPr>
             <a:r>
-              <a:rPr lang="fr-FR" noProof="0" dirty="0">
-                <a:solidFill>
-                  <a:srgbClr val="FFFFFF"/>
+              <a:rPr>
+                <a:solidFill>
+                  <a:srgbClr val="E8E8E8"/>
                 </a:solidFill>
               </a:rPr>
-              <a:t>Batch: 256 | </a:t>
-            </a:r>
-            <a:r>
-              <a:rPr lang="fr-FR" noProof="0" dirty="0" err="1">
-                <a:solidFill>
-                  <a:srgbClr val="FFFFFF"/>
-                </a:solidFill>
-              </a:rPr>
-              <a:t>Epochs</a:t>
-            </a:r>
-            <a:r>
-              <a:rPr lang="fr-FR" noProof="0" dirty="0">
-                <a:solidFill>
-                  <a:srgbClr val="FFFFFF"/>
-                </a:solidFill>
-              </a:rPr>
-              <a:t>: 80</a:t>
-            </a:r>
-          </a:p>
-          <a:p>
-            <a:pPr algn="l">
+              <a:t>Loss: MSE (régression)</a:t>
+            </a:r>
+          </a:p>
+          <a:p>
+            <a:pPr algn="ctr">
               <a:spcBef>
-                <a:spcPts val="400"/>
+                <a:spcPts val="100"/>
               </a:spcBef>
               <a:spcAft>
-                <a:spcPts val="200"/>
+                <a:spcPts val="100"/>
               </a:spcAft>
-              <a:defRPr sz="1200" b="0">
-                <a:solidFill>
-                  <a:srgbClr val="333333"/>
+              <a:defRPr sz="1100" b="0">
+                <a:solidFill>
+                  <a:srgbClr val="E0E0E0"/>
                 </a:solidFill>
                 <a:latin typeface="Calibri"/>
               </a:defRPr>
             </a:pPr>
             <a:r>
-              <a:rPr lang="fr-FR" noProof="0" dirty="0">
-                <a:solidFill>
-                  <a:srgbClr val="FFFFFF"/>
+              <a:rPr>
+                <a:solidFill>
+                  <a:srgbClr val="E8E8E8"/>
                 </a:solidFill>
               </a:rPr>
-              <a:t>Weight </a:t>
-            </a:r>
-            <a:r>
-              <a:rPr lang="fr-FR" noProof="0" dirty="0" err="1">
-                <a:solidFill>
-                  <a:srgbClr val="FFFFFF"/>
-                </a:solidFill>
-              </a:rPr>
-              <a:t>decay</a:t>
-            </a:r>
-            <a:r>
-              <a:rPr lang="fr-FR" noProof="0" dirty="0">
-                <a:solidFill>
-                  <a:srgbClr val="FFFFFF"/>
-                </a:solidFill>
-              </a:rPr>
-              <a:t>: 5e-4 (L2)</a:t>
-            </a:r>
-          </a:p>
-          <a:p>
-            <a:pPr algn="l">
+              <a:t>Batch: 256 | Epochs: 80</a:t>
+            </a:r>
+          </a:p>
+          <a:p>
+            <a:pPr algn="ctr">
               <a:spcBef>
-                <a:spcPts val="400"/>
+                <a:spcPts val="100"/>
               </a:spcBef>
               <a:spcAft>
-                <a:spcPts val="200"/>
+                <a:spcPts val="100"/>
               </a:spcAft>
-              <a:defRPr sz="1200" b="0">
-                <a:solidFill>
-                  <a:srgbClr val="333333"/>
+              <a:defRPr sz="1100" b="0">
+                <a:solidFill>
+                  <a:srgbClr val="E0E0E0"/>
                 </a:solidFill>
                 <a:latin typeface="Calibri"/>
               </a:defRPr>
             </a:pPr>
             <a:r>
-              <a:rPr lang="fr-FR" noProof="0" dirty="0">
-                <a:solidFill>
-                  <a:srgbClr val="FFFFFF"/>
+              <a:rPr>
+                <a:solidFill>
+                  <a:srgbClr val="E8E8E8"/>
+                </a:solidFill>
+              </a:rPr>
+              <a:t>Weight decay: 5e-4 (L2)</a:t>
+            </a:r>
+          </a:p>
+          <a:p>
+            <a:pPr algn="ctr">
+              <a:spcBef>
+                <a:spcPts val="100"/>
+              </a:spcBef>
+              <a:spcAft>
+                <a:spcPts val="100"/>
+              </a:spcAft>
+              <a:defRPr sz="1100" b="0">
+                <a:solidFill>
+                  <a:srgbClr val="E0E0E0"/>
+                </a:solidFill>
+                <a:latin typeface="Calibri"/>
+              </a:defRPr>
+            </a:pPr>
+            <a:r>
+              <a:rPr>
+                <a:solidFill>
+                  <a:srgbClr val="E8E8E8"/>
                 </a:solidFill>
               </a:rPr>
               <a:t>Dropout: 0.3</a:t>
@@ -27663,167 +27572,135 @@
               <a:t>Anti-Surapprentissage</a:t>
             </a:r>
           </a:p>
-        </p:txBody>
-      </p:sp>
-      <p:sp>
-        <p:nvSpPr>
-          <p:cNvPr id="8" name="TextBox 7"/>
-          <p:cNvSpPr txBox="1"/>
-          <p:nvPr/>
-        </p:nvSpPr>
-        <p:spPr>
-          <a:xfrm>
-            <a:off x="8229600" y="2194560"/>
-            <a:ext cx="3291840" cy="1371600"/>
-          </a:xfrm>
-          <a:prstGeom prst="rect">
-            <a:avLst/>
-          </a:prstGeom>
-          <a:noFill/>
-        </p:spPr>
-        <p:txBody>
-          <a:bodyPr wrap="square">
-            <a:spAutoFit/>
-          </a:bodyPr>
-          <a:lstStyle/>
-          <a:p>
-            <a:pPr algn="l">
-              <a:defRPr sz="1200" b="0">
-                <a:solidFill>
-                  <a:srgbClr val="333333"/>
-                </a:solidFill>
-                <a:latin typeface="Calibri"/>
-              </a:defRPr>
-            </a:pPr>
-            <a:r>
-              <a:rPr lang="fr-FR" noProof="0" dirty="0">
-                <a:solidFill>
-                  <a:srgbClr val="FFFFFF"/>
-                </a:solidFill>
-              </a:rPr>
-              <a:t>Dropout(0.3) — désactive 30%</a:t>
-            </a:r>
-          </a:p>
-          <a:p>
-            <a:pPr algn="l">
+          <a:p>
+            <a:pPr>
               <a:spcBef>
                 <a:spcPts val="400"/>
               </a:spcBef>
               <a:spcAft>
                 <a:spcPts val="200"/>
               </a:spcAft>
-              <a:defRPr sz="1200" b="0">
-                <a:solidFill>
-                  <a:srgbClr val="333333"/>
+            </a:pPr>
+          </a:p>
+          <a:p>
+            <a:pPr algn="ctr">
+              <a:spcBef>
+                <a:spcPts val="100"/>
+              </a:spcBef>
+              <a:spcAft>
+                <a:spcPts val="100"/>
+              </a:spcAft>
+              <a:defRPr sz="1100" b="0">
+                <a:solidFill>
+                  <a:srgbClr val="E0E0E0"/>
                 </a:solidFill>
                 <a:latin typeface="Calibri"/>
               </a:defRPr>
             </a:pPr>
             <a:r>
-              <a:rPr lang="fr-FR" noProof="0" dirty="0">
-                <a:solidFill>
-                  <a:srgbClr val="FFFFFF"/>
+              <a:rPr>
+                <a:solidFill>
+                  <a:srgbClr val="E8E8E8"/>
                 </a:solidFill>
               </a:rPr>
-              <a:t>des neurones aléatoirement</a:t>
-            </a:r>
-          </a:p>
-          <a:p>
-            <a:pPr algn="l">
+              <a:t>Dropout(0.3) — désactive 30%</a:t>
+            </a:r>
+          </a:p>
+          <a:p>
+            <a:pPr algn="ctr">
               <a:spcBef>
-                <a:spcPts val="400"/>
+                <a:spcPts val="100"/>
               </a:spcBef>
               <a:spcAft>
-                <a:spcPts val="200"/>
+                <a:spcPts val="100"/>
               </a:spcAft>
-              <a:defRPr sz="1200" b="1">
-                <a:solidFill>
-                  <a:srgbClr val="333333"/>
+              <a:defRPr sz="1100" b="0">
+                <a:solidFill>
+                  <a:srgbClr val="E0E0E0"/>
                 </a:solidFill>
                 <a:latin typeface="Calibri"/>
               </a:defRPr>
             </a:pPr>
             <a:r>
-              <a:rPr lang="fr-FR" noProof="0" dirty="0">
-                <a:solidFill>
-                  <a:srgbClr val="FFFFFF"/>
+              <a:rPr>
+                <a:solidFill>
+                  <a:srgbClr val="E8E8E8"/>
                 </a:solidFill>
               </a:rPr>
-              <a:t>Weight </a:t>
-            </a:r>
-            <a:r>
-              <a:rPr lang="fr-FR" noProof="0" dirty="0" err="1">
-                <a:solidFill>
-                  <a:srgbClr val="FFFFFF"/>
-                </a:solidFill>
-              </a:rPr>
-              <a:t>Decay</a:t>
-            </a:r>
-            <a:r>
-              <a:rPr lang="fr-FR" noProof="0" dirty="0">
-                <a:solidFill>
-                  <a:srgbClr val="FFFFFF"/>
-                </a:solidFill>
-              </a:rPr>
-              <a:t> (L2)</a:t>
-            </a:r>
-          </a:p>
-          <a:p>
-            <a:pPr algn="l">
+              <a:t>des neurones aléatoirement</a:t>
+            </a:r>
+          </a:p>
+          <a:p>
+            <a:pPr algn="ctr">
               <a:spcBef>
-                <a:spcPts val="400"/>
+                <a:spcPts val="100"/>
               </a:spcBef>
               <a:spcAft>
-                <a:spcPts val="200"/>
+                <a:spcPts val="100"/>
               </a:spcAft>
-              <a:defRPr sz="1200" b="0">
-                <a:solidFill>
-                  <a:srgbClr val="333333"/>
+              <a:defRPr sz="1100" b="0">
+                <a:solidFill>
+                  <a:srgbClr val="E0E0E0"/>
                 </a:solidFill>
                 <a:latin typeface="Calibri"/>
               </a:defRPr>
             </a:pPr>
             <a:r>
-              <a:rPr lang="fr-FR" noProof="0" dirty="0">
-                <a:solidFill>
-                  <a:srgbClr val="FFFFFF"/>
+              <a:rPr>
+                <a:solidFill>
+                  <a:srgbClr val="E8E8E8"/>
                 </a:solidFill>
               </a:rPr>
-              <a:t>Tire les poids vers zéro</a:t>
-            </a:r>
-          </a:p>
-          <a:p>
-            <a:pPr algn="l">
+              <a:t>Weight Decay (L2)</a:t>
+            </a:r>
+          </a:p>
+          <a:p>
+            <a:pPr algn="ctr">
               <a:spcBef>
-                <a:spcPts val="400"/>
+                <a:spcPts val="100"/>
               </a:spcBef>
               <a:spcAft>
-                <a:spcPts val="200"/>
+                <a:spcPts val="100"/>
               </a:spcAft>
-              <a:defRPr sz="1200" b="0">
-                <a:solidFill>
-                  <a:srgbClr val="333333"/>
+              <a:defRPr sz="1100" b="0">
+                <a:solidFill>
+                  <a:srgbClr val="E0E0E0"/>
                 </a:solidFill>
                 <a:latin typeface="Calibri"/>
               </a:defRPr>
             </a:pPr>
             <a:r>
-              <a:rPr lang="fr-FR" noProof="0" dirty="0">
-                <a:solidFill>
-                  <a:srgbClr val="FFFFFF"/>
+              <a:rPr>
+                <a:solidFill>
+                  <a:srgbClr val="E8E8E8"/>
                 </a:solidFill>
               </a:rPr>
-              <a:t>Empêche l'explosion des </a:t>
-            </a:r>
-            <a:r>
-              <a:rPr lang="fr-FR" noProof="0" dirty="0" err="1">
-                <a:solidFill>
-                  <a:srgbClr val="FFFFFF"/>
+              <a:t>Tire les poids vers zéro</a:t>
+            </a:r>
+          </a:p>
+          <a:p>
+            <a:pPr algn="ctr">
+              <a:spcBef>
+                <a:spcPts val="100"/>
+              </a:spcBef>
+              <a:spcAft>
+                <a:spcPts val="100"/>
+              </a:spcAft>
+              <a:defRPr sz="1100" b="0">
+                <a:solidFill>
+                  <a:srgbClr val="E0E0E0"/>
+                </a:solidFill>
+                <a:latin typeface="Calibri"/>
+              </a:defRPr>
+            </a:pPr>
+            <a:r>
+              <a:rPr>
+                <a:solidFill>
+                  <a:srgbClr val="E8E8E8"/>
                 </a:solidFill>
               </a:rPr>
-              <a:t>embeddings</a:t>
-            </a:r>
-            <a:endParaRPr lang="fr-FR" noProof="0" dirty="0"/>
+              <a:t>Empêche l'explosion des embeddings</a:t>
+            </a:r>
           </a:p>
         </p:txBody>
       </p:sp>
@@ -27901,7 +27778,7 @@
             <a:r>
               <a:rPr lang="fr-FR" noProof="0" dirty="0">
                 <a:solidFill>
-                  <a:srgbClr val="FFFFFF"/>
+                  <a:srgbClr val="E8E8E8"/>
                 </a:solidFill>
               </a:rPr>
               <a:t>Input [user, item]</a:t>
@@ -27919,7 +27796,7 @@
             <a:r>
               <a:rPr lang="fr-FR" noProof="0" dirty="0">
                 <a:solidFill>
-                  <a:srgbClr val="FFFFFF"/>
+                  <a:srgbClr val="E8E8E8"/>
                 </a:solidFill>
               </a:rPr>
               <a:t>→ NCF → score prédit</a:t>
@@ -28045,7 +27922,7 @@
             <a:r>
               <a:rPr lang="fr-FR" noProof="0" dirty="0">
                 <a:solidFill>
-                  <a:srgbClr val="FFFFFF"/>
+                  <a:srgbClr val="E8E8E8"/>
                 </a:solidFill>
               </a:rPr>
               <a:t>MSE = </a:t>
@@ -28053,7 +27930,7 @@
             <a:r>
               <a:rPr lang="fr-FR" noProof="0" dirty="0" err="1">
                 <a:solidFill>
-                  <a:srgbClr val="FFFFFF"/>
+                  <a:srgbClr val="E8E8E8"/>
                 </a:solidFill>
               </a:rPr>
               <a:t>mean</a:t>
@@ -28061,7 +27938,7 @@
             <a:r>
               <a:rPr lang="fr-FR" noProof="0" dirty="0">
                 <a:solidFill>
-                  <a:srgbClr val="FFFFFF"/>
+                  <a:srgbClr val="E8E8E8"/>
                 </a:solidFill>
               </a:rPr>
               <a:t>(</a:t>
@@ -28079,7 +27956,7 @@
             <a:r>
               <a:rPr lang="fr-FR" noProof="0" dirty="0">
                 <a:solidFill>
-                  <a:srgbClr val="FFFFFF"/>
+                  <a:srgbClr val="E8E8E8"/>
                 </a:solidFill>
               </a:rPr>
               <a:t>(prédit - réel)²)</a:t>
@@ -28214,7 +28091,7 @@
             <a:r>
               <a:rPr lang="fr-FR" noProof="0" dirty="0" err="1">
                 <a:solidFill>
-                  <a:srgbClr val="FFFFFF"/>
+                  <a:srgbClr val="E8E8E8"/>
                 </a:solidFill>
               </a:rPr>
               <a:t>Autograd</a:t>
@@ -28222,7 +28099,7 @@
             <a:r>
               <a:rPr lang="fr-FR" noProof="0" dirty="0">
                 <a:solidFill>
-                  <a:srgbClr val="FFFFFF"/>
+                  <a:srgbClr val="E8E8E8"/>
                 </a:solidFill>
               </a:rPr>
               <a:t> calcule</a:t>
@@ -28240,7 +28117,7 @@
             <a:r>
               <a:rPr lang="fr-FR" noProof="0" dirty="0">
                 <a:solidFill>
-                  <a:srgbClr val="FFFFFF"/>
+                  <a:srgbClr val="E8E8E8"/>
                 </a:solidFill>
               </a:rPr>
               <a:t>∂Loss/∂Param</a:t>
@@ -28366,7 +28243,7 @@
             <a:r>
               <a:rPr lang="fr-FR" noProof="0" dirty="0">
                 <a:solidFill>
-                  <a:srgbClr val="FFFFFF"/>
+                  <a:srgbClr val="E8E8E8"/>
                 </a:solidFill>
               </a:rPr>
               <a:t>Adam ajuste</a:t>
@@ -28384,7 +28261,7 @@
             <a:r>
               <a:rPr lang="fr-FR" noProof="0" dirty="0" err="1">
                 <a:solidFill>
-                  <a:srgbClr val="FFFFFF"/>
+                  <a:srgbClr val="E8E8E8"/>
                 </a:solidFill>
               </a:rPr>
               <a:t>embeddings</a:t>
@@ -28392,7 +28269,7 @@
             <a:r>
               <a:rPr lang="fr-FR" noProof="0" dirty="0">
                 <a:solidFill>
-                  <a:srgbClr val="FFFFFF"/>
+                  <a:srgbClr val="E8E8E8"/>
                 </a:solidFill>
               </a:rPr>
               <a:t> + poids</a:t>

</xml_diff>